<commit_message>
fixed delta hedging monte carlo simulation module, and updated figures
</commit_message>
<xml_diff>
--- a/Project_Slides.pptx
+++ b/Project_Slides.pptx
@@ -847,7 +847,7 @@
           <a:p>
             <a:fld id="{FC36C9A5-BCC8-42D4-B3CC-BDB3B2111420}" type="datetimeFigureOut">
               <a:rPr lang="en-US" smtClean="0"/>
-              <a:t>5/1/2026</a:t>
+              <a:t>10/6/2026</a:t>
             </a:fld>
             <a:endParaRPr lang="en-US"/>
           </a:p>
@@ -1098,7 +1098,7 @@
           <a:p>
             <a:fld id="{FC36C9A5-BCC8-42D4-B3CC-BDB3B2111420}" type="datetimeFigureOut">
               <a:rPr lang="en-US" smtClean="0"/>
-              <a:t>5/1/2026</a:t>
+              <a:t>10/6/2026</a:t>
             </a:fld>
             <a:endParaRPr lang="en-US"/>
           </a:p>
@@ -1412,7 +1412,7 @@
           <a:p>
             <a:fld id="{FC36C9A5-BCC8-42D4-B3CC-BDB3B2111420}" type="datetimeFigureOut">
               <a:rPr lang="en-US" smtClean="0"/>
-              <a:t>5/1/2026</a:t>
+              <a:t>10/6/2026</a:t>
             </a:fld>
             <a:endParaRPr lang="en-US"/>
           </a:p>
@@ -1753,7 +1753,7 @@
           <a:p>
             <a:fld id="{FC36C9A5-BCC8-42D4-B3CC-BDB3B2111420}" type="datetimeFigureOut">
               <a:rPr lang="en-US" smtClean="0"/>
-              <a:t>5/1/2026</a:t>
+              <a:t>10/6/2026</a:t>
             </a:fld>
             <a:endParaRPr lang="en-US"/>
           </a:p>
@@ -2067,7 +2067,7 @@
           <a:p>
             <a:fld id="{FC36C9A5-BCC8-42D4-B3CC-BDB3B2111420}" type="datetimeFigureOut">
               <a:rPr lang="en-US" smtClean="0"/>
-              <a:t>5/1/2026</a:t>
+              <a:t>10/6/2026</a:t>
             </a:fld>
             <a:endParaRPr lang="en-US"/>
           </a:p>
@@ -2460,7 +2460,7 @@
           <a:p>
             <a:fld id="{FC36C9A5-BCC8-42D4-B3CC-BDB3B2111420}" type="datetimeFigureOut">
               <a:rPr lang="en-US" smtClean="0"/>
-              <a:t>5/1/2026</a:t>
+              <a:t>10/6/2026</a:t>
             </a:fld>
             <a:endParaRPr lang="en-US"/>
           </a:p>
@@ -2630,7 +2630,7 @@
           <a:p>
             <a:fld id="{FC36C9A5-BCC8-42D4-B3CC-BDB3B2111420}" type="datetimeFigureOut">
               <a:rPr lang="en-US" smtClean="0"/>
-              <a:t>5/1/2026</a:t>
+              <a:t>10/6/2026</a:t>
             </a:fld>
             <a:endParaRPr lang="en-US"/>
           </a:p>
@@ -2810,7 +2810,7 @@
           <a:p>
             <a:fld id="{FC36C9A5-BCC8-42D4-B3CC-BDB3B2111420}" type="datetimeFigureOut">
               <a:rPr lang="en-US" smtClean="0"/>
-              <a:t>5/1/2026</a:t>
+              <a:t>10/6/2026</a:t>
             </a:fld>
             <a:endParaRPr lang="en-US"/>
           </a:p>
@@ -2986,7 +2986,7 @@
           <a:p>
             <a:fld id="{FC36C9A5-BCC8-42D4-B3CC-BDB3B2111420}" type="datetimeFigureOut">
               <a:rPr lang="en-US" smtClean="0"/>
-              <a:t>5/1/2026</a:t>
+              <a:t>10/6/2026</a:t>
             </a:fld>
             <a:endParaRPr lang="en-US"/>
           </a:p>
@@ -3233,7 +3233,7 @@
           <a:p>
             <a:fld id="{FC36C9A5-BCC8-42D4-B3CC-BDB3B2111420}" type="datetimeFigureOut">
               <a:rPr lang="en-US" smtClean="0"/>
-              <a:t>5/1/2026</a:t>
+              <a:t>10/6/2026</a:t>
             </a:fld>
             <a:endParaRPr lang="en-US"/>
           </a:p>
@@ -3465,7 +3465,7 @@
           <a:p>
             <a:fld id="{FC36C9A5-BCC8-42D4-B3CC-BDB3B2111420}" type="datetimeFigureOut">
               <a:rPr lang="en-US" smtClean="0"/>
-              <a:t>5/1/2026</a:t>
+              <a:t>10/6/2026</a:t>
             </a:fld>
             <a:endParaRPr lang="en-US"/>
           </a:p>
@@ -3839,7 +3839,7 @@
           <a:p>
             <a:fld id="{FC36C9A5-BCC8-42D4-B3CC-BDB3B2111420}" type="datetimeFigureOut">
               <a:rPr lang="en-US" smtClean="0"/>
-              <a:t>5/1/2026</a:t>
+              <a:t>10/6/2026</a:t>
             </a:fld>
             <a:endParaRPr lang="en-US"/>
           </a:p>
@@ -3962,7 +3962,7 @@
           <a:p>
             <a:fld id="{FC36C9A5-BCC8-42D4-B3CC-BDB3B2111420}" type="datetimeFigureOut">
               <a:rPr lang="en-US" smtClean="0"/>
-              <a:t>5/1/2026</a:t>
+              <a:t>10/6/2026</a:t>
             </a:fld>
             <a:endParaRPr lang="en-US"/>
           </a:p>
@@ -4057,7 +4057,7 @@
           <a:p>
             <a:fld id="{FC36C9A5-BCC8-42D4-B3CC-BDB3B2111420}" type="datetimeFigureOut">
               <a:rPr lang="en-US" smtClean="0"/>
-              <a:t>5/1/2026</a:t>
+              <a:t>10/6/2026</a:t>
             </a:fld>
             <a:endParaRPr lang="en-US"/>
           </a:p>
@@ -4312,7 +4312,7 @@
           <a:p>
             <a:fld id="{FC36C9A5-BCC8-42D4-B3CC-BDB3B2111420}" type="datetimeFigureOut">
               <a:rPr lang="en-US" smtClean="0"/>
-              <a:t>5/1/2026</a:t>
+              <a:t>10/6/2026</a:t>
             </a:fld>
             <a:endParaRPr lang="en-US"/>
           </a:p>
@@ -4575,7 +4575,7 @@
           <a:p>
             <a:fld id="{FC36C9A5-BCC8-42D4-B3CC-BDB3B2111420}" type="datetimeFigureOut">
               <a:rPr lang="en-US" smtClean="0"/>
-              <a:t>5/1/2026</a:t>
+              <a:t>10/6/2026</a:t>
             </a:fld>
             <a:endParaRPr lang="en-US"/>
           </a:p>
@@ -5318,7 +5318,7 @@
           <a:p>
             <a:fld id="{FC36C9A5-BCC8-42D4-B3CC-BDB3B2111420}" type="datetimeFigureOut">
               <a:rPr lang="en-US" smtClean="0"/>
-              <a:t>5/1/2026</a:t>
+              <a:t>10/6/2026</a:t>
             </a:fld>
             <a:endParaRPr lang="en-US"/>
           </a:p>
@@ -6283,10 +6283,10 @@
       </p:sp>
       <p:pic>
         <p:nvPicPr>
-          <p:cNvPr id="9" name="Picture 8">
+          <p:cNvPr id="8" name="Picture 7">
             <a:extLst>
               <a:ext uri="{FF2B5EF4-FFF2-40B4-BE49-F238E27FC236}">
-                <a16:creationId xmlns:a16="http://schemas.microsoft.com/office/drawing/2014/main" id="{24064234-33C7-6394-890D-A4CD3AEC4C37}"/>
+                <a16:creationId xmlns:a16="http://schemas.microsoft.com/office/drawing/2014/main" id="{CEFB03DA-29ED-8C31-9643-522B5D50B625}"/>
               </a:ext>
             </a:extLst>
           </p:cNvPr>
@@ -6309,8 +6309,8 @@
         </p:blipFill>
         <p:spPr>
           <a:xfrm>
-            <a:off x="589119" y="1273318"/>
-            <a:ext cx="8476505" cy="5266954"/>
+            <a:off x="438680" y="978285"/>
+            <a:ext cx="8151892" cy="5248666"/>
           </a:xfrm>
           <a:prstGeom prst="rect">
             <a:avLst/>

</xml_diff>